<commit_message>
release(v2.0): 2.0.0a6, Phase 4 outputs (#1)
Version 2.0.0a6 (2.0.0-alpha.6) via tools/release.py; goldens and the
Hazira samples re-rendered at 2026-10-22 (version and date stamps only);
CHANGELOG records the measured blind routing, the png --no-sandbox retry,
brand masking in shared copies and the interview-plan cap of 31.

Co-Authored-By: Claude Opus 5.5 <noreply@anthropic.com>
</commit_message>
<xml_diff>
--- a/samples/2020-09-24-hazira-gas-release-fire/outputs/site-leadership-coach.pptx
+++ b/samples/2020-09-24-hazira-gas-release-fire/outputs/site-leadership-coach.pptx
@@ -8581,7 +8581,7 @@
                   <a:srgbClr val="1F2328"/>
                 </a:solidFill>
               </a:rPr>
-              <a:t>Generated with ProbeMatrix Learnings Coach v2.0.0a5 (open source, MIT) from a ProbeMatrix four-level human-factors investigation. ProbeMatrix by Eyekyam: ashley@eyekyam.com</a:t>
+              <a:t>Generated with ProbeMatrix Learnings Coach v2.0.0a6 (open source, MIT) from a ProbeMatrix four-level human-factors investigation. ProbeMatrix by Eyekyam: ashley@eyekyam.com</a:t>
             </a:r>
             <a:endParaRPr lang="en" sz="1200" dirty="0"/>
           </a:p>
@@ -10939,7 +10939,7 @@
                   <a:srgbClr val="57606A"/>
                 </a:solidFill>
               </a:rPr>
-              <a:t>Learning purposes: not a statutory document · Generated with ProbeMatrix Learnings Coach v2.0.0a5 (open source, MIT) from a ProbeMatrix four-level human-factors investigation. ProbeMatrix by Eyekyam: ashley@eyekyam.com</a:t>
+              <a:t>Learning purposes: not a statutory document · Generated with ProbeMatrix Learnings Coach v2.0.0a6 (open source, MIT) from a ProbeMatrix four-level human-factors investigation. ProbeMatrix by Eyekyam: ashley@eyekyam.com</a:t>
             </a:r>
             <a:endParaRPr lang="en" sz="900" dirty="0"/>
           </a:p>
@@ -11225,7 +11225,7 @@
                   <a:srgbClr val="57606A"/>
                 </a:solidFill>
               </a:rPr>
-              <a:t>Learning purposes: not a statutory document · Generated with ProbeMatrix Learnings Coach v2.0.0a5 (open source, MIT) from a ProbeMatrix four-level human-factors investigation. ProbeMatrix by Eyekyam: ashley@eyekyam.com</a:t>
+              <a:t>Learning purposes: not a statutory document · Generated with ProbeMatrix Learnings Coach v2.0.0a6 (open source, MIT) from a ProbeMatrix four-level human-factors investigation. ProbeMatrix by Eyekyam: ashley@eyekyam.com</a:t>
             </a:r>
             <a:endParaRPr lang="en" sz="900" dirty="0"/>
           </a:p>
@@ -11511,7 +11511,7 @@
                   <a:srgbClr val="57606A"/>
                 </a:solidFill>
               </a:rPr>
-              <a:t>Learning purposes: not a statutory document · Generated with ProbeMatrix Learnings Coach v2.0.0a5 (open source, MIT) from a ProbeMatrix four-level human-factors investigation. ProbeMatrix by Eyekyam: ashley@eyekyam.com</a:t>
+              <a:t>Learning purposes: not a statutory document · Generated with ProbeMatrix Learnings Coach v2.0.0a6 (open source, MIT) from a ProbeMatrix four-level human-factors investigation. ProbeMatrix by Eyekyam: ashley@eyekyam.com</a:t>
             </a:r>
             <a:endParaRPr lang="en" sz="900" dirty="0"/>
           </a:p>
@@ -11797,7 +11797,7 @@
                   <a:srgbClr val="57606A"/>
                 </a:solidFill>
               </a:rPr>
-              <a:t>Learning purposes: not a statutory document · Generated with ProbeMatrix Learnings Coach v2.0.0a5 (open source, MIT) from a ProbeMatrix four-level human-factors investigation. ProbeMatrix by Eyekyam: ashley@eyekyam.com</a:t>
+              <a:t>Learning purposes: not a statutory document · Generated with ProbeMatrix Learnings Coach v2.0.0a6 (open source, MIT) from a ProbeMatrix four-level human-factors investigation. ProbeMatrix by Eyekyam: ashley@eyekyam.com</a:t>
             </a:r>
             <a:endParaRPr lang="en" sz="900" dirty="0"/>
           </a:p>
@@ -12033,7 +12033,7 @@
                   <a:srgbClr val="57606A"/>
                 </a:solidFill>
               </a:rPr>
-              <a:t>Learning purposes: not a statutory document · Generated with ProbeMatrix Learnings Coach v2.0.0a5 (open source, MIT) from a ProbeMatrix four-level human-factors investigation. ProbeMatrix by Eyekyam: ashley@eyekyam.com</a:t>
+              <a:t>Learning purposes: not a statutory document · Generated with ProbeMatrix Learnings Coach v2.0.0a6 (open source, MIT) from a ProbeMatrix four-level human-factors investigation. ProbeMatrix by Eyekyam: ashley@eyekyam.com</a:t>
             </a:r>
             <a:endParaRPr lang="en" sz="900" dirty="0"/>
           </a:p>
@@ -12233,7 +12233,7 @@
                   <a:srgbClr val="57606A"/>
                 </a:solidFill>
               </a:rPr>
-              <a:t>Learning purposes: not a statutory document · Generated with ProbeMatrix Learnings Coach v2.0.0a5 (open source, MIT) from a ProbeMatrix four-level human-factors investigation. ProbeMatrix by Eyekyam: ashley@eyekyam.com</a:t>
+              <a:t>Learning purposes: not a statutory document · Generated with ProbeMatrix Learnings Coach v2.0.0a6 (open source, MIT) from a ProbeMatrix four-level human-factors investigation. ProbeMatrix by Eyekyam: ashley@eyekyam.com</a:t>
             </a:r>
             <a:endParaRPr lang="en" sz="900" dirty="0"/>
           </a:p>
@@ -12469,7 +12469,7 @@
                   <a:srgbClr val="57606A"/>
                 </a:solidFill>
               </a:rPr>
-              <a:t>Learning purposes: not a statutory document · Generated with ProbeMatrix Learnings Coach v2.0.0a5 (open source, MIT) from a ProbeMatrix four-level human-factors investigation. ProbeMatrix by Eyekyam: ashley@eyekyam.com</a:t>
+              <a:t>Learning purposes: not a statutory document · Generated with ProbeMatrix Learnings Coach v2.0.0a6 (open source, MIT) from a ProbeMatrix four-level human-factors investigation. ProbeMatrix by Eyekyam: ashley@eyekyam.com</a:t>
             </a:r>
             <a:endParaRPr lang="en" sz="900" dirty="0"/>
           </a:p>
@@ -12759,7 +12759,7 @@
                   <a:srgbClr val="57606A"/>
                 </a:solidFill>
               </a:rPr>
-              <a:t>Learning purposes: not a statutory document · Generated with ProbeMatrix Learnings Coach v2.0.0a5 (open source, MIT) from a ProbeMatrix four-level human-factors investigation. ProbeMatrix by Eyekyam: ashley@eyekyam.com</a:t>
+              <a:t>Learning purposes: not a statutory document · Generated with ProbeMatrix Learnings Coach v2.0.0a6 (open source, MIT) from a ProbeMatrix four-level human-factors investigation. ProbeMatrix by Eyekyam: ashley@eyekyam.com</a:t>
             </a:r>
             <a:endParaRPr lang="en" sz="900" dirty="0"/>
           </a:p>
@@ -12959,7 +12959,7 @@
                   <a:srgbClr val="57606A"/>
                 </a:solidFill>
               </a:rPr>
-              <a:t>Learning purposes: not a statutory document · Generated with ProbeMatrix Learnings Coach v2.0.0a5 (open source, MIT) from a ProbeMatrix four-level human-factors investigation. ProbeMatrix by Eyekyam: ashley@eyekyam.com</a:t>
+              <a:t>Learning purposes: not a statutory document · Generated with ProbeMatrix Learnings Coach v2.0.0a6 (open source, MIT) from a ProbeMatrix four-level human-factors investigation. ProbeMatrix by Eyekyam: ashley@eyekyam.com</a:t>
             </a:r>
             <a:endParaRPr lang="en" sz="900" dirty="0"/>
           </a:p>
@@ -13231,7 +13231,7 @@
                   <a:srgbClr val="57606A"/>
                 </a:solidFill>
               </a:rPr>
-              <a:t>Learning purposes: not a statutory document · Generated with ProbeMatrix Learnings Coach v2.0.0a5 (open source, MIT) from a ProbeMatrix four-level human-factors investigation. ProbeMatrix by Eyekyam: ashley@eyekyam.com</a:t>
+              <a:t>Learning purposes: not a statutory document · Generated with ProbeMatrix Learnings Coach v2.0.0a6 (open source, MIT) from a ProbeMatrix four-level human-factors investigation. ProbeMatrix by Eyekyam: ashley@eyekyam.com</a:t>
             </a:r>
             <a:endParaRPr lang="en" sz="900" dirty="0"/>
           </a:p>
@@ -13431,7 +13431,7 @@
                   <a:srgbClr val="57606A"/>
                 </a:solidFill>
               </a:rPr>
-              <a:t>Learning purposes: not a statutory document · Generated with ProbeMatrix Learnings Coach v2.0.0a5 (open source, MIT) from a ProbeMatrix four-level human-factors investigation. ProbeMatrix by Eyekyam: ashley@eyekyam.com</a:t>
+              <a:t>Learning purposes: not a statutory document · Generated with ProbeMatrix Learnings Coach v2.0.0a6 (open source, MIT) from a ProbeMatrix four-level human-factors investigation. ProbeMatrix by Eyekyam: ashley@eyekyam.com</a:t>
             </a:r>
             <a:endParaRPr lang="en" sz="900" dirty="0"/>
           </a:p>
@@ -13630,7 +13630,7 @@
                   <a:srgbClr val="57606A"/>
                 </a:solidFill>
               </a:rPr>
-              <a:t>Learning purposes: not a statutory document · Generated with ProbeMatrix Learnings Coach v2.0.0a5 (open source, MIT) from a ProbeMatrix four-level human-factors investigation. ProbeMatrix by Eyekyam: ashley@eyekyam.com</a:t>
+              <a:t>Learning purposes: not a statutory document · Generated with ProbeMatrix Learnings Coach v2.0.0a6 (open source, MIT) from a ProbeMatrix four-level human-factors investigation. ProbeMatrix by Eyekyam: ashley@eyekyam.com</a:t>
             </a:r>
             <a:endParaRPr lang="en" sz="900" dirty="0"/>
           </a:p>
@@ -13786,7 +13786,7 @@
                   <a:srgbClr val="57606A"/>
                 </a:solidFill>
               </a:rPr>
-              <a:t>Learning purposes: not a statutory document · Generated with ProbeMatrix Learnings Coach v2.0.0a5 (open source, MIT) from a ProbeMatrix four-level human-factors investigation. ProbeMatrix by Eyekyam: ashley@eyekyam.com</a:t>
+              <a:t>Learning purposes: not a statutory document · Generated with ProbeMatrix Learnings Coach v2.0.0a6 (open source, MIT) from a ProbeMatrix four-level human-factors investigation. ProbeMatrix by Eyekyam: ashley@eyekyam.com</a:t>
             </a:r>
             <a:endParaRPr lang="en" sz="900" dirty="0"/>
           </a:p>
@@ -15692,7 +15692,7 @@
                   <a:srgbClr val="57606A"/>
                 </a:solidFill>
               </a:rPr>
-              <a:t>Generated with ProbeMatrix Learnings Coach v2.0.0a5 (open source, MIT) from a ProbeMatrix four-level human-factors investigation. ProbeMatrix by Eyekyam: ashley@eyekyam.com</a:t>
+              <a:t>Generated with ProbeMatrix Learnings Coach v2.0.0a6 (open source, MIT) from a ProbeMatrix four-level human-factors investigation. ProbeMatrix by Eyekyam: ashley@eyekyam.com</a:t>
             </a:r>
             <a:endParaRPr lang="en" sz="1400" dirty="0"/>
           </a:p>
@@ -15735,7 +15735,7 @@
                   <a:srgbClr val="57606A"/>
                 </a:solidFill>
               </a:rPr>
-              <a:t>Learning purposes: not a statutory document · Generated with ProbeMatrix Learnings Coach v2.0.0a5 (open source, MIT) from a ProbeMatrix four-level human-factors investigation. ProbeMatrix by Eyekyam: ashley@eyekyam.com</a:t>
+              <a:t>Learning purposes: not a statutory document · Generated with ProbeMatrix Learnings Coach v2.0.0a6 (open source, MIT) from a ProbeMatrix four-level human-factors investigation. ProbeMatrix by Eyekyam: ashley@eyekyam.com</a:t>
             </a:r>
             <a:endParaRPr lang="en" sz="900" dirty="0"/>
           </a:p>
@@ -15934,7 +15934,7 @@
                   <a:srgbClr val="57606A"/>
                 </a:solidFill>
               </a:rPr>
-              <a:t>Learning purposes: not a statutory document · Generated with ProbeMatrix Learnings Coach v2.0.0a5 (open source, MIT) from a ProbeMatrix four-level human-factors investigation. ProbeMatrix by Eyekyam: ashley@eyekyam.com</a:t>
+              <a:t>Learning purposes: not a statutory document · Generated with ProbeMatrix Learnings Coach v2.0.0a6 (open source, MIT) from a ProbeMatrix four-level human-factors investigation. ProbeMatrix by Eyekyam: ashley@eyekyam.com</a:t>
             </a:r>
             <a:endParaRPr lang="en" sz="900" dirty="0"/>
           </a:p>
@@ -16133,7 +16133,7 @@
                   <a:srgbClr val="57606A"/>
                 </a:solidFill>
               </a:rPr>
-              <a:t>Learning purposes: not a statutory document · Generated with ProbeMatrix Learnings Coach v2.0.0a5 (open source, MIT) from a ProbeMatrix four-level human-factors investigation. ProbeMatrix by Eyekyam: ashley@eyekyam.com</a:t>
+              <a:t>Learning purposes: not a statutory document · Generated with ProbeMatrix Learnings Coach v2.0.0a6 (open source, MIT) from a ProbeMatrix four-level human-factors investigation. ProbeMatrix by Eyekyam: ashley@eyekyam.com</a:t>
             </a:r>
             <a:endParaRPr lang="en" sz="900" dirty="0"/>
           </a:p>
@@ -16332,7 +16332,7 @@
                   <a:srgbClr val="57606A"/>
                 </a:solidFill>
               </a:rPr>
-              <a:t>Learning purposes: not a statutory document · Generated with ProbeMatrix Learnings Coach v2.0.0a5 (open source, MIT) from a ProbeMatrix four-level human-factors investigation. ProbeMatrix by Eyekyam: ashley@eyekyam.com</a:t>
+              <a:t>Learning purposes: not a statutory document · Generated with ProbeMatrix Learnings Coach v2.0.0a6 (open source, MIT) from a ProbeMatrix four-level human-factors investigation. ProbeMatrix by Eyekyam: ashley@eyekyam.com</a:t>
             </a:r>
             <a:endParaRPr lang="en" sz="900" dirty="0"/>
           </a:p>
@@ -16618,7 +16618,7 @@
                   <a:srgbClr val="57606A"/>
                 </a:solidFill>
               </a:rPr>
-              <a:t>Learning purposes: not a statutory document · Generated with ProbeMatrix Learnings Coach v2.0.0a5 (open source, MIT) from a ProbeMatrix four-level human-factors investigation. ProbeMatrix by Eyekyam: ashley@eyekyam.com</a:t>
+              <a:t>Learning purposes: not a statutory document · Generated with ProbeMatrix Learnings Coach v2.0.0a6 (open source, MIT) from a ProbeMatrix four-level human-factors investigation. ProbeMatrix by Eyekyam: ashley@eyekyam.com</a:t>
             </a:r>
             <a:endParaRPr lang="en" sz="900" dirty="0"/>
           </a:p>
@@ -16904,7 +16904,7 @@
                   <a:srgbClr val="57606A"/>
                 </a:solidFill>
               </a:rPr>
-              <a:t>Learning purposes: not a statutory document · Generated with ProbeMatrix Learnings Coach v2.0.0a5 (open source, MIT) from a ProbeMatrix four-level human-factors investigation. ProbeMatrix by Eyekyam: ashley@eyekyam.com</a:t>
+              <a:t>Learning purposes: not a statutory document · Generated with ProbeMatrix Learnings Coach v2.0.0a6 (open source, MIT) from a ProbeMatrix four-level human-factors investigation. ProbeMatrix by Eyekyam: ashley@eyekyam.com</a:t>
             </a:r>
             <a:endParaRPr lang="en" sz="900" dirty="0"/>
           </a:p>
@@ -17190,7 +17190,7 @@
                   <a:srgbClr val="57606A"/>
                 </a:solidFill>
               </a:rPr>
-              <a:t>Learning purposes: not a statutory document · Generated with ProbeMatrix Learnings Coach v2.0.0a5 (open source, MIT) from a ProbeMatrix four-level human-factors investigation. ProbeMatrix by Eyekyam: ashley@eyekyam.com</a:t>
+              <a:t>Learning purposes: not a statutory document · Generated with ProbeMatrix Learnings Coach v2.0.0a6 (open source, MIT) from a ProbeMatrix four-level human-factors investigation. ProbeMatrix by Eyekyam: ashley@eyekyam.com</a:t>
             </a:r>
             <a:endParaRPr lang="en" sz="900" dirty="0"/>
           </a:p>
@@ -17476,7 +17476,7 @@
                   <a:srgbClr val="57606A"/>
                 </a:solidFill>
               </a:rPr>
-              <a:t>Learning purposes: not a statutory document · Generated with ProbeMatrix Learnings Coach v2.0.0a5 (open source, MIT) from a ProbeMatrix four-level human-factors investigation. ProbeMatrix by Eyekyam: ashley@eyekyam.com</a:t>
+              <a:t>Learning purposes: not a statutory document · Generated with ProbeMatrix Learnings Coach v2.0.0a6 (open source, MIT) from a ProbeMatrix four-level human-factors investigation. ProbeMatrix by Eyekyam: ashley@eyekyam.com</a:t>
             </a:r>
             <a:endParaRPr lang="en" sz="900" dirty="0"/>
           </a:p>

</xml_diff>

<commit_message>
release(v2.0): 2.0.0a7, Phase 5 new skills wave 1 (#1)
Version 2.0.0a6 -> 2.0.0a7 (tools/release.py); goldens regenerated (footer
version only; HTML hashes verified version-only); Hazira samples re-rendered
at SOURCE_DATE_EPOCH=1793059200 (2026-10-27), dashboard adoption tables now
list the Phase 5 packs. Gate OK: 4679 passed on 3.9 and 3.14, coverage 97%,
185 evals, smoke 34 goldens, check-samples 0.

Co-Authored-By: Claude Opus 5.5 <noreply@anthropic.com>
Claude-Session: https://claude.ai/code/session_011J2b33mikuz2J1RKTx4krR
</commit_message>
<xml_diff>
--- a/samples/2020-09-24-hazira-gas-release-fire/outputs/site-leadership-coach.pptx
+++ b/samples/2020-09-24-hazira-gas-release-fire/outputs/site-leadership-coach.pptx
@@ -8581,7 +8581,7 @@
                   <a:srgbClr val="1F2328"/>
                 </a:solidFill>
               </a:rPr>
-              <a:t>Generated with ProbeMatrix Learnings Coach v2.0.0a6 (open source, MIT) from a ProbeMatrix four-level human-factors investigation. ProbeMatrix by Eyekyam: ashley@eyekyam.com</a:t>
+              <a:t>Generated with ProbeMatrix Learnings Coach v2.0.0a7 (open source, MIT) from a ProbeMatrix four-level human-factors investigation. ProbeMatrix by Eyekyam: ashley@eyekyam.com</a:t>
             </a:r>
             <a:endParaRPr lang="en" sz="1200" dirty="0"/>
           </a:p>
@@ -10939,7 +10939,7 @@
                   <a:srgbClr val="57606A"/>
                 </a:solidFill>
               </a:rPr>
-              <a:t>Learning purposes: not a statutory document · Generated with ProbeMatrix Learnings Coach v2.0.0a6 (open source, MIT) from a ProbeMatrix four-level human-factors investigation. ProbeMatrix by Eyekyam: ashley@eyekyam.com</a:t>
+              <a:t>Learning purposes: not a statutory document · Generated with ProbeMatrix Learnings Coach v2.0.0a7 (open source, MIT) from a ProbeMatrix four-level human-factors investigation. ProbeMatrix by Eyekyam: ashley@eyekyam.com</a:t>
             </a:r>
             <a:endParaRPr lang="en" sz="900" dirty="0"/>
           </a:p>
@@ -11225,7 +11225,7 @@
                   <a:srgbClr val="57606A"/>
                 </a:solidFill>
               </a:rPr>
-              <a:t>Learning purposes: not a statutory document · Generated with ProbeMatrix Learnings Coach v2.0.0a6 (open source, MIT) from a ProbeMatrix four-level human-factors investigation. ProbeMatrix by Eyekyam: ashley@eyekyam.com</a:t>
+              <a:t>Learning purposes: not a statutory document · Generated with ProbeMatrix Learnings Coach v2.0.0a7 (open source, MIT) from a ProbeMatrix four-level human-factors investigation. ProbeMatrix by Eyekyam: ashley@eyekyam.com</a:t>
             </a:r>
             <a:endParaRPr lang="en" sz="900" dirty="0"/>
           </a:p>
@@ -11511,7 +11511,7 @@
                   <a:srgbClr val="57606A"/>
                 </a:solidFill>
               </a:rPr>
-              <a:t>Learning purposes: not a statutory document · Generated with ProbeMatrix Learnings Coach v2.0.0a6 (open source, MIT) from a ProbeMatrix four-level human-factors investigation. ProbeMatrix by Eyekyam: ashley@eyekyam.com</a:t>
+              <a:t>Learning purposes: not a statutory document · Generated with ProbeMatrix Learnings Coach v2.0.0a7 (open source, MIT) from a ProbeMatrix four-level human-factors investigation. ProbeMatrix by Eyekyam: ashley@eyekyam.com</a:t>
             </a:r>
             <a:endParaRPr lang="en" sz="900" dirty="0"/>
           </a:p>
@@ -11797,7 +11797,7 @@
                   <a:srgbClr val="57606A"/>
                 </a:solidFill>
               </a:rPr>
-              <a:t>Learning purposes: not a statutory document · Generated with ProbeMatrix Learnings Coach v2.0.0a6 (open source, MIT) from a ProbeMatrix four-level human-factors investigation. ProbeMatrix by Eyekyam: ashley@eyekyam.com</a:t>
+              <a:t>Learning purposes: not a statutory document · Generated with ProbeMatrix Learnings Coach v2.0.0a7 (open source, MIT) from a ProbeMatrix four-level human-factors investigation. ProbeMatrix by Eyekyam: ashley@eyekyam.com</a:t>
             </a:r>
             <a:endParaRPr lang="en" sz="900" dirty="0"/>
           </a:p>
@@ -12033,7 +12033,7 @@
                   <a:srgbClr val="57606A"/>
                 </a:solidFill>
               </a:rPr>
-              <a:t>Learning purposes: not a statutory document · Generated with ProbeMatrix Learnings Coach v2.0.0a6 (open source, MIT) from a ProbeMatrix four-level human-factors investigation. ProbeMatrix by Eyekyam: ashley@eyekyam.com</a:t>
+              <a:t>Learning purposes: not a statutory document · Generated with ProbeMatrix Learnings Coach v2.0.0a7 (open source, MIT) from a ProbeMatrix four-level human-factors investigation. ProbeMatrix by Eyekyam: ashley@eyekyam.com</a:t>
             </a:r>
             <a:endParaRPr lang="en" sz="900" dirty="0"/>
           </a:p>
@@ -12233,7 +12233,7 @@
                   <a:srgbClr val="57606A"/>
                 </a:solidFill>
               </a:rPr>
-              <a:t>Learning purposes: not a statutory document · Generated with ProbeMatrix Learnings Coach v2.0.0a6 (open source, MIT) from a ProbeMatrix four-level human-factors investigation. ProbeMatrix by Eyekyam: ashley@eyekyam.com</a:t>
+              <a:t>Learning purposes: not a statutory document · Generated with ProbeMatrix Learnings Coach v2.0.0a7 (open source, MIT) from a ProbeMatrix four-level human-factors investigation. ProbeMatrix by Eyekyam: ashley@eyekyam.com</a:t>
             </a:r>
             <a:endParaRPr lang="en" sz="900" dirty="0"/>
           </a:p>
@@ -12469,7 +12469,7 @@
                   <a:srgbClr val="57606A"/>
                 </a:solidFill>
               </a:rPr>
-              <a:t>Learning purposes: not a statutory document · Generated with ProbeMatrix Learnings Coach v2.0.0a6 (open source, MIT) from a ProbeMatrix four-level human-factors investigation. ProbeMatrix by Eyekyam: ashley@eyekyam.com</a:t>
+              <a:t>Learning purposes: not a statutory document · Generated with ProbeMatrix Learnings Coach v2.0.0a7 (open source, MIT) from a ProbeMatrix four-level human-factors investigation. ProbeMatrix by Eyekyam: ashley@eyekyam.com</a:t>
             </a:r>
             <a:endParaRPr lang="en" sz="900" dirty="0"/>
           </a:p>
@@ -12759,7 +12759,7 @@
                   <a:srgbClr val="57606A"/>
                 </a:solidFill>
               </a:rPr>
-              <a:t>Learning purposes: not a statutory document · Generated with ProbeMatrix Learnings Coach v2.0.0a6 (open source, MIT) from a ProbeMatrix four-level human-factors investigation. ProbeMatrix by Eyekyam: ashley@eyekyam.com</a:t>
+              <a:t>Learning purposes: not a statutory document · Generated with ProbeMatrix Learnings Coach v2.0.0a7 (open source, MIT) from a ProbeMatrix four-level human-factors investigation. ProbeMatrix by Eyekyam: ashley@eyekyam.com</a:t>
             </a:r>
             <a:endParaRPr lang="en" sz="900" dirty="0"/>
           </a:p>
@@ -12959,7 +12959,7 @@
                   <a:srgbClr val="57606A"/>
                 </a:solidFill>
               </a:rPr>
-              <a:t>Learning purposes: not a statutory document · Generated with ProbeMatrix Learnings Coach v2.0.0a6 (open source, MIT) from a ProbeMatrix four-level human-factors investigation. ProbeMatrix by Eyekyam: ashley@eyekyam.com</a:t>
+              <a:t>Learning purposes: not a statutory document · Generated with ProbeMatrix Learnings Coach v2.0.0a7 (open source, MIT) from a ProbeMatrix four-level human-factors investigation. ProbeMatrix by Eyekyam: ashley@eyekyam.com</a:t>
             </a:r>
             <a:endParaRPr lang="en" sz="900" dirty="0"/>
           </a:p>
@@ -13231,7 +13231,7 @@
                   <a:srgbClr val="57606A"/>
                 </a:solidFill>
               </a:rPr>
-              <a:t>Learning purposes: not a statutory document · Generated with ProbeMatrix Learnings Coach v2.0.0a6 (open source, MIT) from a ProbeMatrix four-level human-factors investigation. ProbeMatrix by Eyekyam: ashley@eyekyam.com</a:t>
+              <a:t>Learning purposes: not a statutory document · Generated with ProbeMatrix Learnings Coach v2.0.0a7 (open source, MIT) from a ProbeMatrix four-level human-factors investigation. ProbeMatrix by Eyekyam: ashley@eyekyam.com</a:t>
             </a:r>
             <a:endParaRPr lang="en" sz="900" dirty="0"/>
           </a:p>
@@ -13431,7 +13431,7 @@
                   <a:srgbClr val="57606A"/>
                 </a:solidFill>
               </a:rPr>
-              <a:t>Learning purposes: not a statutory document · Generated with ProbeMatrix Learnings Coach v2.0.0a6 (open source, MIT) from a ProbeMatrix four-level human-factors investigation. ProbeMatrix by Eyekyam: ashley@eyekyam.com</a:t>
+              <a:t>Learning purposes: not a statutory document · Generated with ProbeMatrix Learnings Coach v2.0.0a7 (open source, MIT) from a ProbeMatrix four-level human-factors investigation. ProbeMatrix by Eyekyam: ashley@eyekyam.com</a:t>
             </a:r>
             <a:endParaRPr lang="en" sz="900" dirty="0"/>
           </a:p>
@@ -13630,7 +13630,7 @@
                   <a:srgbClr val="57606A"/>
                 </a:solidFill>
               </a:rPr>
-              <a:t>Learning purposes: not a statutory document · Generated with ProbeMatrix Learnings Coach v2.0.0a6 (open source, MIT) from a ProbeMatrix four-level human-factors investigation. ProbeMatrix by Eyekyam: ashley@eyekyam.com</a:t>
+              <a:t>Learning purposes: not a statutory document · Generated with ProbeMatrix Learnings Coach v2.0.0a7 (open source, MIT) from a ProbeMatrix four-level human-factors investigation. ProbeMatrix by Eyekyam: ashley@eyekyam.com</a:t>
             </a:r>
             <a:endParaRPr lang="en" sz="900" dirty="0"/>
           </a:p>
@@ -13786,7 +13786,7 @@
                   <a:srgbClr val="57606A"/>
                 </a:solidFill>
               </a:rPr>
-              <a:t>Learning purposes: not a statutory document · Generated with ProbeMatrix Learnings Coach v2.0.0a6 (open source, MIT) from a ProbeMatrix four-level human-factors investigation. ProbeMatrix by Eyekyam: ashley@eyekyam.com</a:t>
+              <a:t>Learning purposes: not a statutory document · Generated with ProbeMatrix Learnings Coach v2.0.0a7 (open source, MIT) from a ProbeMatrix four-level human-factors investigation. ProbeMatrix by Eyekyam: ashley@eyekyam.com</a:t>
             </a:r>
             <a:endParaRPr lang="en" sz="900" dirty="0"/>
           </a:p>
@@ -15692,7 +15692,7 @@
                   <a:srgbClr val="57606A"/>
                 </a:solidFill>
               </a:rPr>
-              <a:t>Generated with ProbeMatrix Learnings Coach v2.0.0a6 (open source, MIT) from a ProbeMatrix four-level human-factors investigation. ProbeMatrix by Eyekyam: ashley@eyekyam.com</a:t>
+              <a:t>Generated with ProbeMatrix Learnings Coach v2.0.0a7 (open source, MIT) from a ProbeMatrix four-level human-factors investigation. ProbeMatrix by Eyekyam: ashley@eyekyam.com</a:t>
             </a:r>
             <a:endParaRPr lang="en" sz="1400" dirty="0"/>
           </a:p>
@@ -15735,7 +15735,7 @@
                   <a:srgbClr val="57606A"/>
                 </a:solidFill>
               </a:rPr>
-              <a:t>Learning purposes: not a statutory document · Generated with ProbeMatrix Learnings Coach v2.0.0a6 (open source, MIT) from a ProbeMatrix four-level human-factors investigation. ProbeMatrix by Eyekyam: ashley@eyekyam.com</a:t>
+              <a:t>Learning purposes: not a statutory document · Generated with ProbeMatrix Learnings Coach v2.0.0a7 (open source, MIT) from a ProbeMatrix four-level human-factors investigation. ProbeMatrix by Eyekyam: ashley@eyekyam.com</a:t>
             </a:r>
             <a:endParaRPr lang="en" sz="900" dirty="0"/>
           </a:p>
@@ -15934,7 +15934,7 @@
                   <a:srgbClr val="57606A"/>
                 </a:solidFill>
               </a:rPr>
-              <a:t>Learning purposes: not a statutory document · Generated with ProbeMatrix Learnings Coach v2.0.0a6 (open source, MIT) from a ProbeMatrix four-level human-factors investigation. ProbeMatrix by Eyekyam: ashley@eyekyam.com</a:t>
+              <a:t>Learning purposes: not a statutory document · Generated with ProbeMatrix Learnings Coach v2.0.0a7 (open source, MIT) from a ProbeMatrix four-level human-factors investigation. ProbeMatrix by Eyekyam: ashley@eyekyam.com</a:t>
             </a:r>
             <a:endParaRPr lang="en" sz="900" dirty="0"/>
           </a:p>
@@ -16133,7 +16133,7 @@
                   <a:srgbClr val="57606A"/>
                 </a:solidFill>
               </a:rPr>
-              <a:t>Learning purposes: not a statutory document · Generated with ProbeMatrix Learnings Coach v2.0.0a6 (open source, MIT) from a ProbeMatrix four-level human-factors investigation. ProbeMatrix by Eyekyam: ashley@eyekyam.com</a:t>
+              <a:t>Learning purposes: not a statutory document · Generated with ProbeMatrix Learnings Coach v2.0.0a7 (open source, MIT) from a ProbeMatrix four-level human-factors investigation. ProbeMatrix by Eyekyam: ashley@eyekyam.com</a:t>
             </a:r>
             <a:endParaRPr lang="en" sz="900" dirty="0"/>
           </a:p>
@@ -16332,7 +16332,7 @@
                   <a:srgbClr val="57606A"/>
                 </a:solidFill>
               </a:rPr>
-              <a:t>Learning purposes: not a statutory document · Generated with ProbeMatrix Learnings Coach v2.0.0a6 (open source, MIT) from a ProbeMatrix four-level human-factors investigation. ProbeMatrix by Eyekyam: ashley@eyekyam.com</a:t>
+              <a:t>Learning purposes: not a statutory document · Generated with ProbeMatrix Learnings Coach v2.0.0a7 (open source, MIT) from a ProbeMatrix four-level human-factors investigation. ProbeMatrix by Eyekyam: ashley@eyekyam.com</a:t>
             </a:r>
             <a:endParaRPr lang="en" sz="900" dirty="0"/>
           </a:p>
@@ -16618,7 +16618,7 @@
                   <a:srgbClr val="57606A"/>
                 </a:solidFill>
               </a:rPr>
-              <a:t>Learning purposes: not a statutory document · Generated with ProbeMatrix Learnings Coach v2.0.0a6 (open source, MIT) from a ProbeMatrix four-level human-factors investigation. ProbeMatrix by Eyekyam: ashley@eyekyam.com</a:t>
+              <a:t>Learning purposes: not a statutory document · Generated with ProbeMatrix Learnings Coach v2.0.0a7 (open source, MIT) from a ProbeMatrix four-level human-factors investigation. ProbeMatrix by Eyekyam: ashley@eyekyam.com</a:t>
             </a:r>
             <a:endParaRPr lang="en" sz="900" dirty="0"/>
           </a:p>
@@ -16904,7 +16904,7 @@
                   <a:srgbClr val="57606A"/>
                 </a:solidFill>
               </a:rPr>
-              <a:t>Learning purposes: not a statutory document · Generated with ProbeMatrix Learnings Coach v2.0.0a6 (open source, MIT) from a ProbeMatrix four-level human-factors investigation. ProbeMatrix by Eyekyam: ashley@eyekyam.com</a:t>
+              <a:t>Learning purposes: not a statutory document · Generated with ProbeMatrix Learnings Coach v2.0.0a7 (open source, MIT) from a ProbeMatrix four-level human-factors investigation. ProbeMatrix by Eyekyam: ashley@eyekyam.com</a:t>
             </a:r>
             <a:endParaRPr lang="en" sz="900" dirty="0"/>
           </a:p>
@@ -17190,7 +17190,7 @@
                   <a:srgbClr val="57606A"/>
                 </a:solidFill>
               </a:rPr>
-              <a:t>Learning purposes: not a statutory document · Generated with ProbeMatrix Learnings Coach v2.0.0a6 (open source, MIT) from a ProbeMatrix four-level human-factors investigation. ProbeMatrix by Eyekyam: ashley@eyekyam.com</a:t>
+              <a:t>Learning purposes: not a statutory document · Generated with ProbeMatrix Learnings Coach v2.0.0a7 (open source, MIT) from a ProbeMatrix four-level human-factors investigation. ProbeMatrix by Eyekyam: ashley@eyekyam.com</a:t>
             </a:r>
             <a:endParaRPr lang="en" sz="900" dirty="0"/>
           </a:p>
@@ -17476,7 +17476,7 @@
                   <a:srgbClr val="57606A"/>
                 </a:solidFill>
               </a:rPr>
-              <a:t>Learning purposes: not a statutory document · Generated with ProbeMatrix Learnings Coach v2.0.0a6 (open source, MIT) from a ProbeMatrix four-level human-factors investigation. ProbeMatrix by Eyekyam: ashley@eyekyam.com</a:t>
+              <a:t>Learning purposes: not a statutory document · Generated with ProbeMatrix Learnings Coach v2.0.0a7 (open source, MIT) from a ProbeMatrix four-level human-factors investigation. ProbeMatrix by Eyekyam: ashley@eyekyam.com</a:t>
             </a:r>
             <a:endParaRPr lang="en" sz="900" dirty="0"/>
           </a:p>

</xml_diff>